<commit_message>
Update workspace, firestore, incidents, and snort
Add VS Code workspace file; tweak backend logs and messages. Remove outdated “(0 reads)” wording from the users endpoint and drop the “0-Read Mode Active” note in the Firestore listener startup log to reflect the cache/listener behavior. Update Snort start script paths (user/path renamed to Matthew/Year3 and paths quoted). Update generated .pyc files and replace several documentation binaries (pptx, docx, pdf).
</commit_message>
<xml_diff>
--- a/Documentation/SIRA_Viva.pptx
+++ b/Documentation/SIRA_Viva.pptx
@@ -372,22 +372,7 @@
           <a:bodyPr/>
           <a:lstStyle/>
           <a:p>
-            <a:r>
-              <a:rPr lang="en-GB" dirty="0"/>
-              <a:t>Before diving into the dashboard, it’s important to understand the landscape SMEs are operating in. They are heavily targeted right now—59% were attacked in a single 12-month period, costing an average of $3.9 million.</a:t>
-            </a:r>
-          </a:p>
-          <a:p>
-            <a:r>
-              <a:rPr lang="en-GB" dirty="0"/>
-              <a:t>Currently, the market fails SMEs in two ways. First, there is a massive awareness gap; many standard business owners simply don't know they need a security posture until it's too late. Second, for those who are proactive and try to defend themselves, they are forced to rely on free intrusion detection systems because they can't afford a real Security Operations Centre.</a:t>
-            </a:r>
-          </a:p>
-          <a:p>
-            <a:r>
-              <a:rPr lang="en-GB" dirty="0"/>
-              <a:t>The problem is that these free tools spit out walls of highly technical telemetry. The average SME owner doesn't know what to do with that data. It creates alert fatigue, the alerts get ignored, and the business remains vulnerable. S.I.R.A. solves this by acting as an automated translator between those complex tools and the non-technical user.</a:t>
-            </a:r>
+            <a:endParaRPr lang="en-GB" dirty="0"/>
           </a:p>
         </p:txBody>
       </p:sp>
@@ -471,27 +456,6 @@
           <a:bodyPr/>
           <a:lstStyle/>
           <a:p>
-            <a:r>
-              <a:rPr lang="en-GB" dirty="0"/>
-              <a:t>To solve this, I built S.I.R.A.—the Security Incident Response Assistant. Instead of staring at messy logs, S.I.R.A. intercepts those alerts and uses an AI Large Language Model to translate them into plain English. It doesn't just tell the user there is a problem; it provides a custom, step-by-step mitigation playbook tailored specifically to their technical skill level.</a:t>
-            </a:r>
-          </a:p>
-          <a:p>
-            <a:endParaRPr lang="en-GB" dirty="0"/>
-          </a:p>
-          <a:p>
-            <a:r>
-              <a:rPr lang="en-GB" dirty="0"/>
-              <a:t>To really understand its value, we have to look at what else is out there. If an SME wants to solve this today, their options are severely limited. They could buy an enterprise SIEM like Splunk, which is incredibly expensive. They could rely purely on free tools like Suricata, but that just leaves them with raw, unreadable logs. Or, they could hire an analyst for a manual review, which eats up 4 to 8 hours of expensive labour per day.</a:t>
-            </a:r>
-          </a:p>
-          <a:p>
-            <a:r>
-              <a:rPr lang="en-GB" dirty="0"/>
-              <a:t>S.I.R.A. sits perfectly in the middle—acting as an affordable, automated virtual security assistant for businesses that simply can't afford a real one.</a:t>
-            </a:r>
-          </a:p>
-          <a:p>
             <a:endParaRPr lang="en-US" dirty="0"/>
           </a:p>
         </p:txBody>
@@ -576,54 +540,7 @@
           <a:bodyPr/>
           <a:lstStyle/>
           <a:p>
-            <a:r>
-              <a:rPr lang="en-GB" dirty="0"/>
-              <a:t>Now that you understand what S.I.R.A. aims to do, here is a high-level look at how it actually works under the hood.</a:t>
-            </a:r>
-          </a:p>
-          <a:p>
-            <a:r>
-              <a:rPr lang="en-GB" dirty="0"/>
-              <a:t>When creating S.I.R.A, I had to consider security before design and development even began. My absolute first priority was ensuring GDPR compliance. I knew I couldn't just pass raw telemetry to a cloud LLM, so privacy dictated the entire architecture.</a:t>
-            </a:r>
-          </a:p>
-          <a:p>
             <a:endParaRPr lang="en-GB" dirty="0"/>
-          </a:p>
-          <a:p>
-            <a:r>
-              <a:rPr lang="en-GB" dirty="0"/>
-              <a:t>The pipeline starts on the left. A Python watcher continuously monitors a local folder for new system and network alerts. Before anything leaves the local environment, the system uses Regex to scrub sensitive PII. To prevent alert fatigue, I also implemented a custom 'Threat Class'. This evaluates the logs and strips out harmless background noise. That noise is still cleaned and saved locally as a JSON file for complete record-keeping, but it is blocked from clogging up the cloud database or distracting the analyst.</a:t>
-            </a:r>
-          </a:p>
-          <a:p>
-            <a:r>
-              <a:rPr lang="en-GB" dirty="0"/>
-              <a:t>The filtered, cleaned threat data is then securely batched and sent to Google Gemini, which acts as our translation engine.</a:t>
-            </a:r>
-          </a:p>
-          <a:p>
-            <a:endParaRPr lang="en-GB" dirty="0"/>
-          </a:p>
-          <a:p>
-            <a:r>
-              <a:rPr lang="en-GB" dirty="0"/>
-              <a:t>Once the AI generates the mitigation playbook, we don't just dump it into the database. To protect the data at rest, the sensitive text is encrypted using AES-128 before being stored in Firebase.</a:t>
-            </a:r>
-          </a:p>
-          <a:p>
-            <a:r>
-              <a:rPr lang="en-GB" dirty="0"/>
-              <a:t>Finally, on the right side, we have our </a:t>
-            </a:r>
-            <a:r>
-              <a:rPr lang="en-GB" dirty="0" err="1"/>
-              <a:t>FastAPI</a:t>
-            </a:r>
-            <a:r>
-              <a:rPr lang="en-GB" dirty="0"/>
-              <a:t> middleman. This decrypts the data and uses a caching system to serve the results in real-time to the React dashboard. However, because this API handles decryption, securing it became a massive priority. To prevent unauthorised database access from a browser, I implemented a strict API key header constraint. If a request is missing that key, the API completely blocks access and throws a 403 Forbidden error, ensuring the whole pipeline remains secure from end to end.</a:t>
-            </a:r>
           </a:p>
         </p:txBody>
       </p:sp>
@@ -707,112 +624,6 @@
           <a:bodyPr/>
           <a:lstStyle/>
           <a:p>
-            <a:r>
-              <a:rPr lang="en-GB" dirty="0"/>
-              <a:t>For the architecture of S.I.R.A, every technology choice was weighed against the specific limitations of an SME.</a:t>
-            </a:r>
-          </a:p>
-          <a:p>
-            <a:r>
-              <a:rPr lang="en-GB" dirty="0"/>
-              <a:t>Starting with the database: my original plan was to use PostgreSQL. However, I pivoted to Firebase </a:t>
-            </a:r>
-            <a:r>
-              <a:rPr lang="en-GB" dirty="0" err="1"/>
-              <a:t>Firestore</a:t>
-            </a:r>
-            <a:r>
-              <a:rPr lang="en-GB" dirty="0"/>
-              <a:t>. The key reason was its built-in </a:t>
-            </a:r>
-            <a:r>
-              <a:rPr lang="en-GB" sz="1200" kern="1200" dirty="0" err="1">
-                <a:solidFill>
-                  <a:schemeClr val="tx1"/>
-                </a:solidFill>
-                <a:latin typeface="+mn-lt"/>
-                <a:ea typeface="+mn-ea"/>
-                <a:cs typeface="+mn-cs"/>
-              </a:rPr>
-              <a:t>on_snapshot</a:t>
-            </a:r>
-            <a:r>
-              <a:rPr lang="en-GB" dirty="0"/>
-              <a:t> listeners. This gave me real-time UI updates without having to engineer a custom WebSocket server from scratch, drastically reducing infrastructure complexity. But to offer an honest critique: because it's NoSQL, complex relational queries—like filtering incidents by a specific subnet and an assigned analyst at the same time—are very difficult. For version two, I would definitely migrate back to a relational database.</a:t>
-            </a:r>
-          </a:p>
-          <a:p>
-            <a:r>
-              <a:rPr lang="en-GB" dirty="0"/>
-              <a:t>For the backend, I chose </a:t>
-            </a:r>
-            <a:r>
-              <a:rPr lang="en-GB" dirty="0" err="1"/>
-              <a:t>FastAPI</a:t>
-            </a:r>
-            <a:r>
-              <a:rPr lang="en-GB" dirty="0"/>
-              <a:t> over Flask or Django. The native </a:t>
-            </a:r>
-            <a:r>
-              <a:rPr lang="en-GB" sz="1200" kern="1200" dirty="0">
-                <a:solidFill>
-                  <a:schemeClr val="tx1"/>
-                </a:solidFill>
-                <a:latin typeface="+mn-lt"/>
-                <a:ea typeface="+mn-ea"/>
-                <a:cs typeface="+mn-cs"/>
-              </a:rPr>
-              <a:t>async</a:t>
-            </a:r>
-            <a:r>
-              <a:rPr lang="en-GB" dirty="0"/>
-              <a:t> support was absolutely essential so the server wouldn't block while waiting for the AI to respond. Paired with </a:t>
-            </a:r>
-            <a:r>
-              <a:rPr lang="en-GB" dirty="0" err="1"/>
-              <a:t>Pydantic</a:t>
-            </a:r>
-            <a:r>
-              <a:rPr lang="en-GB" dirty="0"/>
-              <a:t> for strict data validation, it made building a secure API much faster.</a:t>
-            </a:r>
-          </a:p>
-          <a:p>
-            <a:r>
-              <a:rPr lang="en-GB" dirty="0"/>
-              <a:t>On the frontend, I used React with TypeScript. Plain HTML and JavaScript wouldn't suffice here. React allowed me to reuse components like the </a:t>
-            </a:r>
-            <a:r>
-              <a:rPr lang="en-GB" dirty="0" err="1"/>
-              <a:t>StatCards</a:t>
-            </a:r>
-            <a:r>
-              <a:rPr lang="en-GB" dirty="0"/>
-              <a:t> and integrate the Recharts library seamlessly, while TypeScript ensured type safety across a growing codebase.</a:t>
-            </a:r>
-          </a:p>
-          <a:p>
-            <a:r>
-              <a:rPr lang="en-GB" dirty="0"/>
-              <a:t>For the AI engine, I used Gemini 1.5 Flash-Lite. I originally considered running a local model like Llama 3 for maximum privacy, but I had to rule it out—SMEs simply do not have the expensive GPU hardware required to run it. Gemini's free tier was perfect for the prototype, though at scale, I would re-evaluate GPT-4 for potentially stronger summarisation.</a:t>
-            </a:r>
-          </a:p>
-          <a:p>
-            <a:r>
-              <a:rPr lang="en-GB" dirty="0"/>
-              <a:t>Finally, for data security at rest, I implemented AES-128 encryption using Fernet. I couldn't use something like </a:t>
-            </a:r>
-            <a:r>
-              <a:rPr lang="en-GB" dirty="0" err="1"/>
-              <a:t>bcrypt</a:t>
-            </a:r>
-            <a:r>
-              <a:rPr lang="en-GB" dirty="0"/>
-              <a:t>, because that is a one-way hash, and we need to decrypt the data to read it. AES provides authenticated encryption, meaning the data cannot be silently tampered with. My honest critique here is that the symmetric key is currently stored in a local environment variable. For a production environment, I would upgrade this to a dedicated Key Management Service, like AWS KMS, to ensure enterprise-grade key rotation and security.</a:t>
-            </a:r>
-          </a:p>
-          <a:p>
             <a:endParaRPr lang="en-US" dirty="0"/>
           </a:p>
         </p:txBody>
@@ -897,46 +708,6 @@
           <a:bodyPr/>
           <a:lstStyle/>
           <a:p>
-            <a:r>
-              <a:rPr lang="en-GB" dirty="0"/>
-              <a:t>During the testing phase, I discovered two major architectural bottlenecks that would have made this system completely unviable for a business to run.</a:t>
-            </a:r>
-          </a:p>
-          <a:p>
-            <a:r>
-              <a:rPr lang="en-GB" dirty="0"/>
-              <a:t>The first was database quota exhaustion. Initially, the React frontend was reading directly from </a:t>
-            </a:r>
-            <a:r>
-              <a:rPr lang="en-GB" dirty="0" err="1"/>
-              <a:t>Firestore</a:t>
-            </a:r>
-            <a:r>
-              <a:rPr lang="en-GB" dirty="0"/>
-              <a:t>. During stress testing, the free-tier quota of 50,000 reads per day was maxed out in just a few hours. To fix this, I engineered a solution called '</a:t>
-            </a:r>
-            <a:r>
-              <a:rPr lang="en-GB" dirty="0" err="1"/>
-              <a:t>PyCache</a:t>
-            </a:r>
-            <a:r>
-              <a:rPr lang="en-GB" dirty="0"/>
-              <a:t>'. I replaced all frontend database queries with a Python in-memory RAM cache. Now, a single background listener keeps Python updated, and the React dashboard reads exclusively from that local RAM. The result was massive: database reads per user request dropped to zero, and dashboard latency improved significantly.</a:t>
-            </a:r>
-          </a:p>
-          <a:p>
-            <a:r>
-              <a:rPr lang="en-GB" dirty="0"/>
-              <a:t>The second bottleneck was the AI API. Originally, I was calling Google Gemini once per log line. When I simulated a 500-event burst, it fired 500 individual API calls, immediately triggering HTTP 429 Rate Limit errors and crashing the pipeline. To solve this, I built a UUID Batch Queue. Logs are buffered in-memory up to 50 lines per batch. The system makes one single API call for the whole batch, and uses unique UUIDs to map the AI's bulk response back to the individual incidents in the database.</a:t>
-            </a:r>
-          </a:p>
-          <a:p>
-            <a:r>
-              <a:rPr lang="en-GB" dirty="0"/>
-              <a:t>By combining this with a 60-second delay between calls, API requests went from hundreds per minute down to roughly one per batch, resulting in zero rejected requests and 100% data retention during my final stress tests.</a:t>
-            </a:r>
-          </a:p>
-          <a:p>
             <a:endParaRPr lang="en-US" dirty="0"/>
           </a:p>
         </p:txBody>
@@ -1020,38 +791,6 @@
         <p:txBody>
           <a:bodyPr/>
           <a:lstStyle/>
-          <a:p>
-            <a:r>
-              <a:rPr lang="en-GB" dirty="0"/>
-              <a:t>To conclude, I want to critically evaluate the current state of S.I.R.A and outline exactly how the architecture must evolve to reach true enterprise readiness.</a:t>
-            </a:r>
-          </a:p>
-          <a:p>
-            <a:r>
-              <a:rPr lang="en-GB" dirty="0"/>
-              <a:t>During integration testing, I identified a significant limitation regarding authentication. Network inspection revealed that the Firebase API key is currently exposed within the frontend headers. While functional for a local prototype, this is a security risk in production. To resolve this, the next iteration will route all authentication requests securely through the </a:t>
-            </a:r>
-            <a:r>
-              <a:rPr lang="en-GB" dirty="0" err="1"/>
-              <a:t>FastAPI</a:t>
-            </a:r>
-            <a:r>
-              <a:rPr lang="en-GB" dirty="0"/>
-              <a:t> backend, implementing Firebase JSON Web Tokens to establish true zero-trust session management.</a:t>
-            </a:r>
-          </a:p>
-          <a:p>
-            <a:r>
-              <a:rPr lang="en-GB" dirty="0"/>
-              <a:t>Secondly, the log ingestion pipeline requires structural refinement. Currently, the Python watcher is executed manually via a terminal. Because it lacks a background service mode, a crash means unprocessed logs lose their read-state, forcing the script to restart from line one and risking duplicate database entries. To evolve this, the script must be packaged as a native, always-on Windows or Linux service. Furthermore, to support enterprise scalability, I plan to migrate the architecture to AWS Lambda and replace Firebase with PostgreSQL to unlock complex SQL querying capabilities.</a:t>
-            </a:r>
-          </a:p>
-          <a:p>
-            <a:r>
-              <a:rPr lang="en-GB" dirty="0"/>
-              <a:t>Finally, evaluating the AI integration. User Acceptance Testing exposed a flaw in my prompt engineering: the 'Business Owner' persona occasionally instructed users to 'escalate to an IT team'. This directly contradicts the reality of micro-SMEs, which often have no IT staff. While I have applied initial fixes, the prompting requires continuous tuning. Moving forward—and based directly on a request from my UAT group—the system will be upgraded to map AI summaries directly to the MITRE ATT&amp;CK framework. By aggregating this long-term data and feeding it back into the LLM, S.I.R.A will be capable of generating automated, weekly security posture reports.</a:t>
-            </a:r>
-          </a:p>
           <a:p>
             <a:endParaRPr lang="en-US" dirty="0"/>
           </a:p>
@@ -3762,7 +3501,7 @@
                 <a:ea typeface="Calibri" pitchFamily="34" charset="-122"/>
                 <a:cs typeface="Calibri" pitchFamily="34" charset="-120"/>
               </a:rPr>
-              <a:t>vs. Splunk: ~$150/GB/day  ·  vs. Suricata: raw logs only, no context  ·  vs. manual review: 4–8hrs per analyst per day</a:t>
+              <a:t>vs. Splunk: ~$150/GB/day  ·  vs. Snort: raw logs only, no context  ·  vs. manual review: 4–8hrs per analyst per day</a:t>
             </a:r>
             <a:endParaRPr lang="en-US" sz="1050" dirty="0"/>
           </a:p>
@@ -4331,7 +4070,7 @@
                 <a:ea typeface="Calibri" pitchFamily="34" charset="-122"/>
                 <a:cs typeface="Calibri" pitchFamily="34" charset="-120"/>
               </a:rPr>
-              <a:t>Python script</a:t>
+              <a:t>Remove Noise</a:t>
             </a:r>
             <a:endParaRPr lang="en-US" sz="950" dirty="0"/>
           </a:p>
@@ -5926,7 +5665,7 @@
           <p:nvPr>
             <p:extLst>
               <p:ext uri="{D42A27DB-BD31-4B8C-83A1-F6EECF244321}">
-                <p14:modId xmlns:p14="http://schemas.microsoft.com/office/powerpoint/2010/main" val="3935889448"/>
+                <p14:modId xmlns:p14="http://schemas.microsoft.com/office/powerpoint/2010/main" val="718854763"/>
               </p:ext>
             </p:extLst>
           </p:nvPr>
@@ -6601,7 +6340,7 @@
                           <a:ea typeface="Calibri" pitchFamily="34" charset="-122"/>
                           <a:cs typeface="Calibri" pitchFamily="34" charset="-120"/>
                         </a:rPr>
-                        <a:t>NoSQL makes complex relational queries very hard (e.g. filter by subnet + analyst). Would migrate for v2.</a:t>
+                        <a:t>NoSQL makes complex relational queries very hard. Would migrate for v2.</a:t>
                       </a:r>
                       <a:endParaRPr lang="en-US" sz="950" dirty="0">
                         <a:latin typeface="Calibri" charset="0"/>
@@ -6803,7 +6542,7 @@
                           <a:ea typeface="Calibri" pitchFamily="34" charset="-122"/>
                           <a:cs typeface="Calibri" pitchFamily="34" charset="-120"/>
                         </a:rPr>
-                        <a:t>Flask / Django</a:t>
+                        <a:t>Flask </a:t>
                       </a:r>
                       <a:endParaRPr lang="en-US" sz="950" dirty="0">
                         <a:latin typeface="Calibri" charset="0"/>
@@ -9347,7 +9086,7 @@
                 <a:ea typeface="Calibri" pitchFamily="34" charset="-122"/>
                 <a:cs typeface="Calibri" pitchFamily="34" charset="-120"/>
               </a:rPr>
-              <a:t>UAT revealed the 'Business Owner' persona occasionally tells users to 'escalate to an IT team' — directly contradicting the reality of micro-SMEs with no IT staff. Prompt may need further tuning.</a:t>
+              <a:t>UAT revealed the 'Business Owner' persona occasionally tells users to 'escalate to an IT team' — directly contradicting the reality of micro-SMEs with no IT staff. Applied initial fixes but prompt may need further tuning.</a:t>
             </a:r>
             <a:endParaRPr lang="en-US" sz="950" dirty="0"/>
           </a:p>

</xml_diff>